<commit_message>
Dokumentasi tier berat dan pengujian: buku, README, dokumen audit
Buku dokumentasi dibangun ulang (Markdown + PDF/DOCX/PPTX): panduan tier
1.700.000, variabel lingkungan DOMINO_THREADS / DOMINO_MAX_ENGINE /
DOMINO_ENGINE_WAIT, daftar alat audit, serta bagian pengujian yang kini
memuat 29 tes server, 8 tes paralel/determinisme, dan 6 uji antarmuka tanpa
kepala. README menambah jalur pengujian dan alat audit.

Baru: docs/audit-kualitas-kode.md — temuan audit (crash pool kosong, alokasi di
jalur panas, simulasi satu inti, antrean server, cache-first) beserta angka ukur
dan batasannya.
</commit_message>
<xml_diff>
--- a/docs/Domino-Analyzer-Pro-Presentasi.pptx
+++ b/docs/Domino-Analyzer-Pro-Presentasi.pptx
@@ -5856,7 +5856,7 @@
                   <a:srgbClr val="8B949E"/>
                 </a:solidFill>
               </a:rPr>
-              <a:t>Versi aplikasi v3.3 · engine 3.0.0  ·  presentasi dibangun 2026-10-12</a:t>
+              <a:t>Versi aplikasi v3.3 · engine 3.0.0  ·  presentasi dibangun 2026-10-15</a:t>
             </a:r>
           </a:p>
         </p:txBody>
@@ -12993,7 +12993,7 @@
                   <a:srgbClr val="E6EDF3"/>
                 </a:solidFill>
               </a:rPr>
-              <a:t>· 27 uji server: normalisasi, validasi, endpoint, dan kontrak keamanan</a:t>
+              <a:t>· 29 uji server: normalisasi, validasi, endpoint, dan kontrak keamanan</a:t>
             </a:r>
           </a:p>
           <a:p>
@@ -13008,6 +13008,21 @@
                   <a:srgbClr val="E6EDF3"/>
                 </a:solidFill>
               </a:rPr>
+              <a:t>· 6 uji antarmuka tanpa kepala: peringatan tier 1,7 juta, label tombol, Batal mematikan mesin</a:t>
+            </a:r>
+          </a:p>
+          <a:p>
+            <a:pPr>
+              <a:spcAft>
+                <a:spcPts val="1100"/>
+              </a:spcAft>
+            </a:pPr>
+            <a:r>
+              <a:rPr sz="1650" b="0" i="0">
+                <a:solidFill>
+                  <a:srgbClr val="E6EDF3"/>
+                </a:solidFill>
+              </a:rPr>
               <a:t>· Kontrak yang dijaga: ok:false selalu berpasangan dengan status bukan 200</a:t>
             </a:r>
           </a:p>
@@ -13023,7 +13038,7 @@
                   <a:srgbClr val="E6EDF3"/>
                 </a:solidFill>
               </a:rPr>
-              <a:t>· CI menjalankan tiga pekerjaan: Linux g++, Windows MSVC, dan server tanpa mesin</a:t>
+              <a:t>· CI menjalankan empat pekerjaan: Linux g++, Windows MSVC, server tanpa mesin, dan peramban tanpa kepala</a:t>
             </a:r>
           </a:p>
           <a:p>
@@ -15011,7 +15026,7 @@
                   <a:srgbClr val="E6EDF3"/>
                 </a:solidFill>
               </a:rPr>
-              <a:t>· Buku: docs/Domino-Analyzer-Pro-Dokumentasi.pdf (68 halaman, 9 diagram vektor)</a:t>
+              <a:t>· Buku: docs/Domino-Analyzer-Pro-Dokumentasi.pdf (75 halaman, 9 diagram vektor)</a:t>
             </a:r>
           </a:p>
           <a:p>
@@ -17197,7 +17212,23 @@
                 </a:solidFill>
                 <a:latin typeface="Consolas"/>
               </a:rPr>
-              <a:t>python tools/test_server.py             # 27 uji server</a:t>
+              <a:t>python tools/test_server.py             # 29 uji server</a:t>
+            </a:r>
+          </a:p>
+          <a:p>
+            <a:pPr>
+              <a:spcAft>
+                <a:spcPts val="600"/>
+              </a:spcAft>
+            </a:pPr>
+            <a:r>
+              <a:rPr sz="1300" b="0" i="0">
+                <a:solidFill>
+                  <a:srgbClr val="B8D4FF"/>
+                </a:solidFill>
+                <a:latin typeface="Consolas"/>
+              </a:rPr>
+              <a:t>python tools/test_ui_heavy.py           # 6 uji UI tanpa kepala (1,7 juta)</a:t>
             </a:r>
           </a:p>
         </p:txBody>
@@ -17520,7 +17551,22 @@
                   <a:srgbClr val="E6EDF3"/>
                 </a:solidFill>
               </a:rPr>
-              <a:t>· Simulasi per kartu: 500 sampai 5000 (bawaan 2000)</a:t>
+              <a:t>· Simulasi per kartu: 1000 / 5000 / 10000 (bawaan) / 50000 / 1,7 juta</a:t>
+            </a:r>
+          </a:p>
+          <a:p>
+            <a:pPr>
+              <a:spcAft>
+                <a:spcPts val="1100"/>
+              </a:spcAft>
+            </a:pPr>
+            <a:r>
+              <a:rPr sz="1650" b="0" i="0">
+                <a:solidFill>
+                  <a:srgbClr val="E6EDF3"/>
+                </a:solidFill>
+              </a:rPr>
+              <a:t>· Tier 1,7 juta: peringatan waktu, tanpa mode Live, bisa dibatalkan</a:t>
             </a:r>
           </a:p>
           <a:p>

</xml_diff>